<commit_message>
Added PBR and Fatigue constraints
</commit_message>
<xml_diff>
--- a/Slides/DemoSlides.pptx
+++ b/Slides/DemoSlides.pptx
@@ -7,6 +7,7 @@
   <p:sldIdLst>
     <p:sldId id="256" r:id="rId2"/>
     <p:sldId id="257" r:id="rId3"/>
+    <p:sldId id="258" r:id="rId4"/>
   </p:sldIdLst>
   <p:sldSz cx="12192000" cy="6858000"/>
   <p:notesSz cx="6858000" cy="9144000"/>
@@ -3420,10 +3421,10 @@
       </p:grpSpPr>
       <p:pic>
         <p:nvPicPr>
-          <p:cNvPr id="4" name="Picture 3">
-            <a:extLst>
-              <a:ext uri="{FF2B5EF4-FFF2-40B4-BE49-F238E27FC236}">
-                <a16:creationId xmlns:a16="http://schemas.microsoft.com/office/drawing/2014/main" id="{500F203D-95CE-38EB-1F2D-833BE36BF639}"/>
+          <p:cNvPr id="7" name="Picture 6">
+            <a:extLst>
+              <a:ext uri="{FF2B5EF4-FFF2-40B4-BE49-F238E27FC236}">
+                <a16:creationId xmlns:a16="http://schemas.microsoft.com/office/drawing/2014/main" id="{1C1672B8-A795-AAE4-1570-B619215A8001}"/>
               </a:ext>
             </a:extLst>
           </p:cNvPr>
@@ -3440,8 +3441,8 @@
         </p:blipFill>
         <p:spPr>
           <a:xfrm>
-            <a:off x="0" y="34589"/>
-            <a:ext cx="7849280" cy="1554615"/>
+            <a:off x="436691" y="3504154"/>
+            <a:ext cx="3467400" cy="2880610"/>
           </a:xfrm>
           <a:prstGeom prst="rect">
             <a:avLst/>
@@ -3450,10 +3451,10 @@
       </p:pic>
       <p:pic>
         <p:nvPicPr>
-          <p:cNvPr id="7" name="Picture 6">
-            <a:extLst>
-              <a:ext uri="{FF2B5EF4-FFF2-40B4-BE49-F238E27FC236}">
-                <a16:creationId xmlns:a16="http://schemas.microsoft.com/office/drawing/2014/main" id="{1C1672B8-A795-AAE4-1570-B619215A8001}"/>
+          <p:cNvPr id="11" name="Picture 10">
+            <a:extLst>
+              <a:ext uri="{FF2B5EF4-FFF2-40B4-BE49-F238E27FC236}">
+                <a16:creationId xmlns:a16="http://schemas.microsoft.com/office/drawing/2014/main" id="{80B6FB3C-6208-AE67-13E0-1503E2B80A3C}"/>
               </a:ext>
             </a:extLst>
           </p:cNvPr>
@@ -3470,8 +3471,8 @@
         </p:blipFill>
         <p:spPr>
           <a:xfrm>
-            <a:off x="457240" y="3771282"/>
-            <a:ext cx="3467400" cy="2880610"/>
+            <a:off x="4278472" y="3504154"/>
+            <a:ext cx="3635055" cy="2979678"/>
           </a:xfrm>
           <a:prstGeom prst="rect">
             <a:avLst/>
@@ -3480,10 +3481,10 @@
       </p:pic>
       <p:pic>
         <p:nvPicPr>
-          <p:cNvPr id="11" name="Picture 10">
-            <a:extLst>
-              <a:ext uri="{FF2B5EF4-FFF2-40B4-BE49-F238E27FC236}">
-                <a16:creationId xmlns:a16="http://schemas.microsoft.com/office/drawing/2014/main" id="{80B6FB3C-6208-AE67-13E0-1503E2B80A3C}"/>
+          <p:cNvPr id="13" name="Picture 12">
+            <a:extLst>
+              <a:ext uri="{FF2B5EF4-FFF2-40B4-BE49-F238E27FC236}">
+                <a16:creationId xmlns:a16="http://schemas.microsoft.com/office/drawing/2014/main" id="{132E0CBD-D10B-6CC2-797F-928AE8FB7653}"/>
               </a:ext>
             </a:extLst>
           </p:cNvPr>
@@ -3500,8 +3501,8 @@
         </p:blipFill>
         <p:spPr>
           <a:xfrm>
-            <a:off x="4278472" y="3698940"/>
-            <a:ext cx="3635055" cy="2979678"/>
+            <a:off x="8480738" y="3385865"/>
+            <a:ext cx="3711262" cy="2972058"/>
           </a:xfrm>
           <a:prstGeom prst="rect">
             <a:avLst/>
@@ -3510,10 +3511,10 @@
       </p:pic>
       <p:pic>
         <p:nvPicPr>
-          <p:cNvPr id="13" name="Picture 12">
-            <a:extLst>
-              <a:ext uri="{FF2B5EF4-FFF2-40B4-BE49-F238E27FC236}">
-                <a16:creationId xmlns:a16="http://schemas.microsoft.com/office/drawing/2014/main" id="{132E0CBD-D10B-6CC2-797F-928AE8FB7653}"/>
+          <p:cNvPr id="15" name="Picture 14">
+            <a:extLst>
+              <a:ext uri="{FF2B5EF4-FFF2-40B4-BE49-F238E27FC236}">
+                <a16:creationId xmlns:a16="http://schemas.microsoft.com/office/drawing/2014/main" id="{2AB2C20D-DCFB-B06F-700E-6D651A0552CF}"/>
               </a:ext>
             </a:extLst>
           </p:cNvPr>
@@ -3530,37 +3531,7 @@
         </p:blipFill>
         <p:spPr>
           <a:xfrm>
-            <a:off x="8480738" y="3679834"/>
-            <a:ext cx="3711262" cy="2972058"/>
-          </a:xfrm>
-          <a:prstGeom prst="rect">
-            <a:avLst/>
-          </a:prstGeom>
-        </p:spPr>
-      </p:pic>
-      <p:pic>
-        <p:nvPicPr>
-          <p:cNvPr id="15" name="Picture 14">
-            <a:extLst>
-              <a:ext uri="{FF2B5EF4-FFF2-40B4-BE49-F238E27FC236}">
-                <a16:creationId xmlns:a16="http://schemas.microsoft.com/office/drawing/2014/main" id="{2AB2C20D-DCFB-B06F-700E-6D651A0552CF}"/>
-              </a:ext>
-            </a:extLst>
-          </p:cNvPr>
-          <p:cNvPicPr>
-            <a:picLocks noChangeAspect="1"/>
-          </p:cNvPicPr>
-          <p:nvPr/>
-        </p:nvPicPr>
-        <p:blipFill>
-          <a:blip r:embed="rId6"/>
-          <a:stretch>
-            <a:fillRect/>
-          </a:stretch>
-        </p:blipFill>
-        <p:spPr>
-          <a:xfrm>
-            <a:off x="130151" y="1779301"/>
+            <a:off x="78781" y="700514"/>
             <a:ext cx="6210838" cy="1668925"/>
           </a:xfrm>
           <a:prstGeom prst="rect">
@@ -3572,6 +3543,162 @@
     <p:extLst>
       <p:ext uri="{BB962C8B-B14F-4D97-AF65-F5344CB8AC3E}">
         <p14:creationId xmlns:p14="http://schemas.microsoft.com/office/powerpoint/2010/main" val="3817978717"/>
+      </p:ext>
+    </p:extLst>
+  </p:cSld>
+  <p:clrMapOvr>
+    <a:masterClrMapping/>
+  </p:clrMapOvr>
+</p:sld>
+</file>
+
+<file path=ppt/slides/slide3.xml><?xml version="1.0" encoding="utf-8"?>
+<p:sld xmlns:a="http://schemas.openxmlformats.org/drawingml/2006/main" xmlns:r="http://schemas.openxmlformats.org/officeDocument/2006/relationships" xmlns:p="http://schemas.openxmlformats.org/presentationml/2006/main">
+  <p:cSld>
+    <p:spTree>
+      <p:nvGrpSpPr>
+        <p:cNvPr id="1" name="">
+          <a:extLst>
+            <a:ext uri="{FF2B5EF4-FFF2-40B4-BE49-F238E27FC236}">
+              <a16:creationId xmlns:a16="http://schemas.microsoft.com/office/drawing/2014/main" id="{9C57F268-7B3E-547B-5812-D69658E90D88}"/>
+            </a:ext>
+          </a:extLst>
+        </p:cNvPr>
+        <p:cNvGrpSpPr/>
+        <p:nvPr/>
+      </p:nvGrpSpPr>
+      <p:grpSpPr>
+        <a:xfrm>
+          <a:off x="0" y="0"/>
+          <a:ext cx="0" cy="0"/>
+          <a:chOff x="0" y="0"/>
+          <a:chExt cx="0" cy="0"/>
+        </a:xfrm>
+      </p:grpSpPr>
+      <p:pic>
+        <p:nvPicPr>
+          <p:cNvPr id="3" name="Picture 2">
+            <a:extLst>
+              <a:ext uri="{FF2B5EF4-FFF2-40B4-BE49-F238E27FC236}">
+                <a16:creationId xmlns:a16="http://schemas.microsoft.com/office/drawing/2014/main" id="{A1054CB3-B300-E238-99FB-D90953DB24DC}"/>
+              </a:ext>
+            </a:extLst>
+          </p:cNvPr>
+          <p:cNvPicPr>
+            <a:picLocks noChangeAspect="1"/>
+          </p:cNvPicPr>
+          <p:nvPr/>
+        </p:nvPicPr>
+        <p:blipFill>
+          <a:blip r:embed="rId2"/>
+          <a:stretch>
+            <a:fillRect/>
+          </a:stretch>
+        </p:blipFill>
+        <p:spPr>
+          <a:xfrm>
+            <a:off x="240561" y="3838435"/>
+            <a:ext cx="3407159" cy="2803808"/>
+          </a:xfrm>
+          <a:prstGeom prst="rect">
+            <a:avLst/>
+          </a:prstGeom>
+        </p:spPr>
+      </p:pic>
+      <p:pic>
+        <p:nvPicPr>
+          <p:cNvPr id="6" name="Picture 5">
+            <a:extLst>
+              <a:ext uri="{FF2B5EF4-FFF2-40B4-BE49-F238E27FC236}">
+                <a16:creationId xmlns:a16="http://schemas.microsoft.com/office/drawing/2014/main" id="{BCDDADE6-213F-7AB7-C093-F404343BC858}"/>
+              </a:ext>
+            </a:extLst>
+          </p:cNvPr>
+          <p:cNvPicPr>
+            <a:picLocks noChangeAspect="1"/>
+          </p:cNvPicPr>
+          <p:nvPr/>
+        </p:nvPicPr>
+        <p:blipFill>
+          <a:blip r:embed="rId3"/>
+          <a:stretch>
+            <a:fillRect/>
+          </a:stretch>
+        </p:blipFill>
+        <p:spPr>
+          <a:xfrm>
+            <a:off x="3884948" y="3838435"/>
+            <a:ext cx="3481573" cy="2803808"/>
+          </a:xfrm>
+          <a:prstGeom prst="rect">
+            <a:avLst/>
+          </a:prstGeom>
+        </p:spPr>
+      </p:pic>
+      <p:pic>
+        <p:nvPicPr>
+          <p:cNvPr id="9" name="Picture 8">
+            <a:extLst>
+              <a:ext uri="{FF2B5EF4-FFF2-40B4-BE49-F238E27FC236}">
+                <a16:creationId xmlns:a16="http://schemas.microsoft.com/office/drawing/2014/main" id="{60ABA67D-8FB3-96FD-A576-A4485661FACA}"/>
+              </a:ext>
+            </a:extLst>
+          </p:cNvPr>
+          <p:cNvPicPr>
+            <a:picLocks noChangeAspect="1"/>
+          </p:cNvPicPr>
+          <p:nvPr/>
+        </p:nvPicPr>
+        <p:blipFill>
+          <a:blip r:embed="rId4"/>
+          <a:stretch>
+            <a:fillRect/>
+          </a:stretch>
+        </p:blipFill>
+        <p:spPr>
+          <a:xfrm>
+            <a:off x="8237207" y="3713644"/>
+            <a:ext cx="3485710" cy="2928599"/>
+          </a:xfrm>
+          <a:prstGeom prst="rect">
+            <a:avLst/>
+          </a:prstGeom>
+        </p:spPr>
+      </p:pic>
+      <p:pic>
+        <p:nvPicPr>
+          <p:cNvPr id="12" name="Picture 11">
+            <a:extLst>
+              <a:ext uri="{FF2B5EF4-FFF2-40B4-BE49-F238E27FC236}">
+                <a16:creationId xmlns:a16="http://schemas.microsoft.com/office/drawing/2014/main" id="{D1B238B2-0CDE-6762-1EC7-C5246B67EDAE}"/>
+              </a:ext>
+            </a:extLst>
+          </p:cNvPr>
+          <p:cNvPicPr>
+            <a:picLocks noChangeAspect="1"/>
+          </p:cNvPicPr>
+          <p:nvPr/>
+        </p:nvPicPr>
+        <p:blipFill>
+          <a:blip r:embed="rId5"/>
+          <a:stretch>
+            <a:fillRect/>
+          </a:stretch>
+        </p:blipFill>
+        <p:spPr>
+          <a:xfrm>
+            <a:off x="240561" y="2046977"/>
+            <a:ext cx="5819048" cy="1666667"/>
+          </a:xfrm>
+          <a:prstGeom prst="rect">
+            <a:avLst/>
+          </a:prstGeom>
+        </p:spPr>
+      </p:pic>
+    </p:spTree>
+    <p:extLst>
+      <p:ext uri="{BB962C8B-B14F-4D97-AF65-F5344CB8AC3E}">
+        <p14:creationId xmlns:p14="http://schemas.microsoft.com/office/powerpoint/2010/main" val="986234404"/>
       </p:ext>
     </p:extLst>
   </p:cSld>

</xml_diff>

<commit_message>
Fixed bug in sensitivity of stress failure factor
</commit_message>
<xml_diff>
--- a/Slides/DemoSlides.pptx
+++ b/Slides/DemoSlides.pptx
@@ -7,8 +7,9 @@
   <p:sldIdLst>
     <p:sldId id="256" r:id="rId2"/>
     <p:sldId id="259" r:id="rId3"/>
-    <p:sldId id="257" r:id="rId4"/>
-    <p:sldId id="258" r:id="rId5"/>
+    <p:sldId id="260" r:id="rId4"/>
+    <p:sldId id="257" r:id="rId5"/>
+    <p:sldId id="258" r:id="rId6"/>
   </p:sldIdLst>
   <p:sldSz cx="12192000" cy="6858000"/>
   <p:notesSz cx="6858000" cy="9144000"/>
@@ -262,7 +263,7 @@
           <a:p>
             <a:fld id="{F452D536-55A4-4DB8-BD69-D62233374E62}" type="datetimeFigureOut">
               <a:rPr lang="en-US" smtClean="0"/>
-              <a:t>11/19/2025</a:t>
+              <a:t>11/20/2025</a:t>
             </a:fld>
             <a:endParaRPr lang="en-US"/>
           </a:p>
@@ -460,7 +461,7 @@
           <a:p>
             <a:fld id="{F452D536-55A4-4DB8-BD69-D62233374E62}" type="datetimeFigureOut">
               <a:rPr lang="en-US" smtClean="0"/>
-              <a:t>11/19/2025</a:t>
+              <a:t>11/20/2025</a:t>
             </a:fld>
             <a:endParaRPr lang="en-US"/>
           </a:p>
@@ -668,7 +669,7 @@
           <a:p>
             <a:fld id="{F452D536-55A4-4DB8-BD69-D62233374E62}" type="datetimeFigureOut">
               <a:rPr lang="en-US" smtClean="0"/>
-              <a:t>11/19/2025</a:t>
+              <a:t>11/20/2025</a:t>
             </a:fld>
             <a:endParaRPr lang="en-US"/>
           </a:p>
@@ -866,7 +867,7 @@
           <a:p>
             <a:fld id="{F452D536-55A4-4DB8-BD69-D62233374E62}" type="datetimeFigureOut">
               <a:rPr lang="en-US" smtClean="0"/>
-              <a:t>11/19/2025</a:t>
+              <a:t>11/20/2025</a:t>
             </a:fld>
             <a:endParaRPr lang="en-US"/>
           </a:p>
@@ -1141,7 +1142,7 @@
           <a:p>
             <a:fld id="{F452D536-55A4-4DB8-BD69-D62233374E62}" type="datetimeFigureOut">
               <a:rPr lang="en-US" smtClean="0"/>
-              <a:t>11/19/2025</a:t>
+              <a:t>11/20/2025</a:t>
             </a:fld>
             <a:endParaRPr lang="en-US"/>
           </a:p>
@@ -1406,7 +1407,7 @@
           <a:p>
             <a:fld id="{F452D536-55A4-4DB8-BD69-D62233374E62}" type="datetimeFigureOut">
               <a:rPr lang="en-US" smtClean="0"/>
-              <a:t>11/19/2025</a:t>
+              <a:t>11/20/2025</a:t>
             </a:fld>
             <a:endParaRPr lang="en-US"/>
           </a:p>
@@ -1818,7 +1819,7 @@
           <a:p>
             <a:fld id="{F452D536-55A4-4DB8-BD69-D62233374E62}" type="datetimeFigureOut">
               <a:rPr lang="en-US" smtClean="0"/>
-              <a:t>11/19/2025</a:t>
+              <a:t>11/20/2025</a:t>
             </a:fld>
             <a:endParaRPr lang="en-US"/>
           </a:p>
@@ -1959,7 +1960,7 @@
           <a:p>
             <a:fld id="{F452D536-55A4-4DB8-BD69-D62233374E62}" type="datetimeFigureOut">
               <a:rPr lang="en-US" smtClean="0"/>
-              <a:t>11/19/2025</a:t>
+              <a:t>11/20/2025</a:t>
             </a:fld>
             <a:endParaRPr lang="en-US"/>
           </a:p>
@@ -2072,7 +2073,7 @@
           <a:p>
             <a:fld id="{F452D536-55A4-4DB8-BD69-D62233374E62}" type="datetimeFigureOut">
               <a:rPr lang="en-US" smtClean="0"/>
-              <a:t>11/19/2025</a:t>
+              <a:t>11/20/2025</a:t>
             </a:fld>
             <a:endParaRPr lang="en-US"/>
           </a:p>
@@ -2383,7 +2384,7 @@
           <a:p>
             <a:fld id="{F452D536-55A4-4DB8-BD69-D62233374E62}" type="datetimeFigureOut">
               <a:rPr lang="en-US" smtClean="0"/>
-              <a:t>11/19/2025</a:t>
+              <a:t>11/20/2025</a:t>
             </a:fld>
             <a:endParaRPr lang="en-US"/>
           </a:p>
@@ -2671,7 +2672,7 @@
           <a:p>
             <a:fld id="{F452D536-55A4-4DB8-BD69-D62233374E62}" type="datetimeFigureOut">
               <a:rPr lang="en-US" smtClean="0"/>
-              <a:t>11/19/2025</a:t>
+              <a:t>11/20/2025</a:t>
             </a:fld>
             <a:endParaRPr lang="en-US"/>
           </a:p>
@@ -2912,7 +2913,7 @@
           <a:p>
             <a:fld id="{F452D536-55A4-4DB8-BD69-D62233374E62}" type="datetimeFigureOut">
               <a:rPr lang="en-US" smtClean="0"/>
-              <a:t>11/19/2025</a:t>
+              <a:t>11/20/2025</a:t>
             </a:fld>
             <a:endParaRPr lang="en-US"/>
           </a:p>
@@ -3442,7 +3443,7 @@
         </p:blipFill>
         <p:spPr>
           <a:xfrm>
-            <a:off x="77822" y="1047207"/>
+            <a:off x="391970" y="2856261"/>
             <a:ext cx="3729692" cy="3022336"/>
           </a:xfrm>
           <a:prstGeom prst="rect">
@@ -3464,7 +3465,7 @@
         </p:nvSpPr>
         <p:spPr>
           <a:xfrm>
-            <a:off x="896540" y="227022"/>
+            <a:off x="702087" y="268899"/>
             <a:ext cx="1762598" cy="369332"/>
           </a:xfrm>
           <a:prstGeom prst="rect">
@@ -3487,10 +3488,10 @@
       </p:sp>
       <p:sp>
         <p:nvSpPr>
-          <p:cNvPr id="5" name="TextBox 4">
-            <a:extLst>
-              <a:ext uri="{FF2B5EF4-FFF2-40B4-BE49-F238E27FC236}">
-                <a16:creationId xmlns:a16="http://schemas.microsoft.com/office/drawing/2014/main" id="{7AF6705D-0920-7F5B-66ED-59364D5DFA08}"/>
+          <p:cNvPr id="6" name="TextBox 5">
+            <a:extLst>
+              <a:ext uri="{FF2B5EF4-FFF2-40B4-BE49-F238E27FC236}">
+                <a16:creationId xmlns:a16="http://schemas.microsoft.com/office/drawing/2014/main" id="{422F3590-1FD7-ABAB-39B9-99286E3ED5D9}"/>
               </a:ext>
             </a:extLst>
           </p:cNvPr>
@@ -3499,8 +3500,8 @@
         </p:nvSpPr>
         <p:spPr>
           <a:xfrm>
-            <a:off x="1093998" y="4299625"/>
-            <a:ext cx="1393330" cy="369332"/>
+            <a:off x="5981071" y="45908"/>
+            <a:ext cx="3456972" cy="369332"/>
           </a:xfrm>
           <a:prstGeom prst="rect">
             <a:avLst/>
@@ -3515,17 +3516,17 @@
           <a:p>
             <a:r>
               <a:rPr lang="en-US" b="1" dirty="0"/>
-              <a:t>Mass = 29.6</a:t>
-            </a:r>
-          </a:p>
-        </p:txBody>
-      </p:sp>
-      <p:sp>
-        <p:nvSpPr>
-          <p:cNvPr id="6" name="TextBox 5">
-            <a:extLst>
-              <a:ext uri="{FF2B5EF4-FFF2-40B4-BE49-F238E27FC236}">
-                <a16:creationId xmlns:a16="http://schemas.microsoft.com/office/drawing/2014/main" id="{422F3590-1FD7-ABAB-39B9-99286E3ED5D9}"/>
+              <a:t>Multiple materials (No thermal)</a:t>
+            </a:r>
+          </a:p>
+        </p:txBody>
+      </p:sp>
+      <p:sp>
+        <p:nvSpPr>
+          <p:cNvPr id="2" name="TextBox 1">
+            <a:extLst>
+              <a:ext uri="{FF2B5EF4-FFF2-40B4-BE49-F238E27FC236}">
+                <a16:creationId xmlns:a16="http://schemas.microsoft.com/office/drawing/2014/main" id="{18F4A0D6-2515-54A1-2224-2673F73482CF}"/>
               </a:ext>
             </a:extLst>
           </p:cNvPr>
@@ -3534,8 +3535,8 @@
         </p:nvSpPr>
         <p:spPr>
           <a:xfrm>
-            <a:off x="4755178" y="126503"/>
-            <a:ext cx="2100832" cy="369332"/>
+            <a:off x="1165331" y="647288"/>
+            <a:ext cx="1225015" cy="923330"/>
           </a:xfrm>
           <a:prstGeom prst="rect">
             <a:avLst/>
@@ -3550,17 +3551,98 @@
           <a:p>
             <a:r>
               <a:rPr lang="en-US" b="1" dirty="0"/>
-              <a:t>Multiple materials</a:t>
-            </a:r>
-          </a:p>
-        </p:txBody>
-      </p:sp>
+              <a:t>E = 2.1e11</a:t>
+            </a:r>
+          </a:p>
+          <a:p>
+            <a:r>
+              <a:rPr lang="en-US" b="1" dirty="0"/>
+              <a:t>Y = 2.5e8</a:t>
+            </a:r>
+          </a:p>
+          <a:p>
+            <a:r>
+              <a:rPr lang="en-US" b="1" dirty="0">
+                <a:latin typeface="Symbol" panose="05050102010706020507" pitchFamily="18" charset="2"/>
+              </a:rPr>
+              <a:t>r</a:t>
+            </a:r>
+            <a:r>
+              <a:rPr lang="en-US" b="1" dirty="0"/>
+              <a:t> = 7850</a:t>
+            </a:r>
+          </a:p>
+        </p:txBody>
+      </p:sp>
+      <p:graphicFrame>
+        <p:nvGraphicFramePr>
+          <p:cNvPr id="7" name="Object 6">
+            <a:extLst>
+              <a:ext uri="{FF2B5EF4-FFF2-40B4-BE49-F238E27FC236}">
+                <a16:creationId xmlns:a16="http://schemas.microsoft.com/office/drawing/2014/main" id="{5761FA89-8ECE-52A1-A767-749A311401C8}"/>
+              </a:ext>
+            </a:extLst>
+          </p:cNvPr>
+          <p:cNvGraphicFramePr>
+            <a:graphicFrameLocks noChangeAspect="1"/>
+          </p:cNvGraphicFramePr>
+          <p:nvPr>
+            <p:extLst>
+              <p:ext uri="{D42A27DB-BD31-4B8C-83A1-F6EECF244321}">
+                <p14:modId xmlns:p14="http://schemas.microsoft.com/office/powerpoint/2010/main" val="117426502"/>
+              </p:ext>
+            </p:extLst>
+          </p:nvPr>
+        </p:nvGraphicFramePr>
+        <p:xfrm>
+          <a:off x="1060179" y="1799524"/>
+          <a:ext cx="1196637" cy="739739"/>
+        </p:xfrm>
+        <a:graphic>
+          <a:graphicData uri="http://schemas.openxmlformats.org/presentationml/2006/ole">
+            <mc:AlternateContent xmlns:mc="http://schemas.openxmlformats.org/markup-compatibility/2006">
+              <mc:Choice xmlns:v="urn:schemas-microsoft-com:vml" Requires="v">
+                <p:oleObj name="Equation" r:id="rId3" imgW="698400" imgH="431640" progId="Equation.DSMT4">
+                  <p:embed/>
+                </p:oleObj>
+              </mc:Choice>
+              <mc:Fallback>
+                <p:oleObj name="Equation" r:id="rId3" imgW="698400" imgH="431640" progId="Equation.DSMT4">
+                  <p:embed/>
+                  <p:pic>
+                    <p:nvPicPr>
+                      <p:cNvPr id="0" name=""/>
+                      <p:cNvPicPr/>
+                      <p:nvPr/>
+                    </p:nvPicPr>
+                    <p:blipFill>
+                      <a:blip r:embed="rId4"/>
+                      <a:stretch>
+                        <a:fillRect/>
+                      </a:stretch>
+                    </p:blipFill>
+                    <p:spPr>
+                      <a:xfrm>
+                        <a:off x="1060179" y="1799524"/>
+                        <a:ext cx="1196637" cy="739739"/>
+                      </a:xfrm>
+                      <a:prstGeom prst="rect">
+                        <a:avLst/>
+                      </a:prstGeom>
+                    </p:spPr>
+                  </p:pic>
+                </p:oleObj>
+              </mc:Fallback>
+            </mc:AlternateContent>
+          </a:graphicData>
+        </a:graphic>
+      </p:graphicFrame>
       <p:pic>
         <p:nvPicPr>
-          <p:cNvPr id="9" name="Picture 8">
-            <a:extLst>
-              <a:ext uri="{FF2B5EF4-FFF2-40B4-BE49-F238E27FC236}">
-                <a16:creationId xmlns:a16="http://schemas.microsoft.com/office/drawing/2014/main" id="{2E75FBB4-A93A-72C5-227F-F99629800803}"/>
+          <p:cNvPr id="12" name="Picture 11">
+            <a:extLst>
+              <a:ext uri="{FF2B5EF4-FFF2-40B4-BE49-F238E27FC236}">
+                <a16:creationId xmlns:a16="http://schemas.microsoft.com/office/drawing/2014/main" id="{2CA947EE-DFAB-4189-6EDD-B3868091EE85}"/>
               </a:ext>
             </a:extLst>
           </p:cNvPr>
@@ -3570,15 +3652,299 @@
           <p:nvPr/>
         </p:nvPicPr>
         <p:blipFill>
-          <a:blip r:embed="rId3"/>
+          <a:blip r:embed="rId5"/>
           <a:stretch>
             <a:fillRect/>
           </a:stretch>
         </p:blipFill>
         <p:spPr>
           <a:xfrm>
-            <a:off x="4139323" y="961037"/>
-            <a:ext cx="3085024" cy="3338588"/>
+            <a:off x="4517166" y="442769"/>
+            <a:ext cx="5651686" cy="1168419"/>
+          </a:xfrm>
+          <a:prstGeom prst="rect">
+            <a:avLst/>
+          </a:prstGeom>
+        </p:spPr>
+      </p:pic>
+      <p:sp>
+        <p:nvSpPr>
+          <p:cNvPr id="14" name="TextBox 13">
+            <a:extLst>
+              <a:ext uri="{FF2B5EF4-FFF2-40B4-BE49-F238E27FC236}">
+                <a16:creationId xmlns:a16="http://schemas.microsoft.com/office/drawing/2014/main" id="{260E044F-6B1D-9914-E1D2-BAF1F90DA53B}"/>
+              </a:ext>
+            </a:extLst>
+          </p:cNvPr>
+          <p:cNvSpPr txBox="1"/>
+          <p:nvPr/>
+        </p:nvSpPr>
+        <p:spPr>
+          <a:xfrm>
+            <a:off x="10168852" y="906515"/>
+            <a:ext cx="1817101" cy="369332"/>
+          </a:xfrm>
+          <a:prstGeom prst="rect">
+            <a:avLst/>
+          </a:prstGeom>
+          <a:noFill/>
+        </p:spPr>
+        <p:txBody>
+          <a:bodyPr wrap="none" rtlCol="0">
+            <a:spAutoFit/>
+          </a:bodyPr>
+          <a:lstStyle/>
+          <a:p>
+            <a:r>
+              <a:rPr lang="en-US" dirty="0"/>
+              <a:t>2D latent space</a:t>
+            </a:r>
+          </a:p>
+        </p:txBody>
+      </p:sp>
+      <p:sp>
+        <p:nvSpPr>
+          <p:cNvPr id="15" name="Rectangle 14">
+            <a:extLst>
+              <a:ext uri="{FF2B5EF4-FFF2-40B4-BE49-F238E27FC236}">
+                <a16:creationId xmlns:a16="http://schemas.microsoft.com/office/drawing/2014/main" id="{55AAB2DC-24E3-82CD-F35F-05A6DF503181}"/>
+              </a:ext>
+            </a:extLst>
+          </p:cNvPr>
+          <p:cNvSpPr/>
+          <p:nvPr/>
+        </p:nvSpPr>
+        <p:spPr>
+          <a:xfrm>
+            <a:off x="4517166" y="904672"/>
+            <a:ext cx="5651686" cy="204281"/>
+          </a:xfrm>
+          <a:prstGeom prst="rect">
+            <a:avLst/>
+          </a:prstGeom>
+          <a:noFill/>
+          <a:ln>
+            <a:solidFill>
+              <a:srgbClr val="FF0000"/>
+            </a:solidFill>
+          </a:ln>
+        </p:spPr>
+        <p:style>
+          <a:lnRef idx="2">
+            <a:schemeClr val="accent1">
+              <a:shade val="15000"/>
+            </a:schemeClr>
+          </a:lnRef>
+          <a:fillRef idx="1">
+            <a:schemeClr val="accent1"/>
+          </a:fillRef>
+          <a:effectRef idx="0">
+            <a:schemeClr val="accent1"/>
+          </a:effectRef>
+          <a:fontRef idx="minor">
+            <a:schemeClr val="lt1"/>
+          </a:fontRef>
+        </p:style>
+        <p:txBody>
+          <a:bodyPr rtlCol="0" anchor="ctr"/>
+          <a:lstStyle/>
+          <a:p>
+            <a:pPr algn="ctr"/>
+            <a:endParaRPr lang="en-US">
+              <a:noFill/>
+            </a:endParaRPr>
+          </a:p>
+        </p:txBody>
+      </p:sp>
+      <p:sp>
+        <p:nvSpPr>
+          <p:cNvPr id="23" name="TextBox 22">
+            <a:extLst>
+              <a:ext uri="{FF2B5EF4-FFF2-40B4-BE49-F238E27FC236}">
+                <a16:creationId xmlns:a16="http://schemas.microsoft.com/office/drawing/2014/main" id="{D95E1C9A-EF30-37C0-FEF7-B93FB40771B8}"/>
+              </a:ext>
+            </a:extLst>
+          </p:cNvPr>
+          <p:cNvSpPr txBox="1"/>
+          <p:nvPr/>
+        </p:nvSpPr>
+        <p:spPr>
+          <a:xfrm>
+            <a:off x="1243878" y="5887546"/>
+            <a:ext cx="1146468" cy="646331"/>
+          </a:xfrm>
+          <a:prstGeom prst="rect">
+            <a:avLst/>
+          </a:prstGeom>
+          <a:noFill/>
+        </p:spPr>
+        <p:txBody>
+          <a:bodyPr wrap="none" rtlCol="0">
+            <a:spAutoFit/>
+          </a:bodyPr>
+          <a:lstStyle/>
+          <a:p>
+            <a:r>
+              <a:rPr lang="en-US" b="1" dirty="0"/>
+              <a:t>M* = 29.7</a:t>
+            </a:r>
+          </a:p>
+          <a:p>
+            <a:r>
+              <a:rPr lang="en-US" b="1" dirty="0">
+                <a:latin typeface="Symbol" panose="05050102010706020507" pitchFamily="18" charset="2"/>
+              </a:rPr>
+              <a:t>s</a:t>
+            </a:r>
+            <a:r>
+              <a:rPr lang="en-US" b="1" dirty="0"/>
+              <a:t>*= 0.5</a:t>
+            </a:r>
+          </a:p>
+        </p:txBody>
+      </p:sp>
+      <p:sp>
+        <p:nvSpPr>
+          <p:cNvPr id="24" name="TextBox 23">
+            <a:extLst>
+              <a:ext uri="{FF2B5EF4-FFF2-40B4-BE49-F238E27FC236}">
+                <a16:creationId xmlns:a16="http://schemas.microsoft.com/office/drawing/2014/main" id="{1958853A-133A-9CA7-0B4D-1DDE7244C039}"/>
+              </a:ext>
+            </a:extLst>
+          </p:cNvPr>
+          <p:cNvSpPr txBox="1"/>
+          <p:nvPr/>
+        </p:nvSpPr>
+        <p:spPr>
+          <a:xfrm>
+            <a:off x="5209377" y="5877727"/>
+            <a:ext cx="1135247" cy="646331"/>
+          </a:xfrm>
+          <a:prstGeom prst="rect">
+            <a:avLst/>
+          </a:prstGeom>
+          <a:noFill/>
+        </p:spPr>
+        <p:txBody>
+          <a:bodyPr wrap="none" rtlCol="0">
+            <a:spAutoFit/>
+          </a:bodyPr>
+          <a:lstStyle/>
+          <a:p>
+            <a:r>
+              <a:rPr lang="en-US" b="1" dirty="0"/>
+              <a:t>M* = 29.5</a:t>
+            </a:r>
+          </a:p>
+          <a:p>
+            <a:r>
+              <a:rPr lang="en-US" b="1" dirty="0">
+                <a:latin typeface="Symbol" panose="05050102010706020507" pitchFamily="18" charset="2"/>
+              </a:rPr>
+              <a:t>s</a:t>
+            </a:r>
+            <a:r>
+              <a:rPr lang="en-US" b="1" dirty="0"/>
+              <a:t>*= 0.48</a:t>
+            </a:r>
+            <a:endParaRPr lang="en-US" b="1" dirty="0">
+              <a:solidFill>
+                <a:srgbClr val="FF0000"/>
+              </a:solidFill>
+            </a:endParaRPr>
+          </a:p>
+        </p:txBody>
+      </p:sp>
+      <p:sp>
+        <p:nvSpPr>
+          <p:cNvPr id="26" name="TextBox 25">
+            <a:extLst>
+              <a:ext uri="{FF2B5EF4-FFF2-40B4-BE49-F238E27FC236}">
+                <a16:creationId xmlns:a16="http://schemas.microsoft.com/office/drawing/2014/main" id="{8BF68B30-2962-28E0-8289-C17BB8606559}"/>
+              </a:ext>
+            </a:extLst>
+          </p:cNvPr>
+          <p:cNvSpPr txBox="1"/>
+          <p:nvPr/>
+        </p:nvSpPr>
+        <p:spPr>
+          <a:xfrm>
+            <a:off x="6472896" y="1855814"/>
+            <a:ext cx="1570173" cy="369332"/>
+          </a:xfrm>
+          <a:prstGeom prst="rect">
+            <a:avLst/>
+          </a:prstGeom>
+          <a:noFill/>
+        </p:spPr>
+        <p:txBody>
+          <a:bodyPr wrap="none" rtlCol="0">
+            <a:spAutoFit/>
+          </a:bodyPr>
+          <a:lstStyle/>
+          <a:p>
+            <a:pPr algn="ctr"/>
+            <a:r>
+              <a:rPr lang="en-US" b="1" dirty="0"/>
+              <a:t>Init: Heaviest</a:t>
+            </a:r>
+          </a:p>
+        </p:txBody>
+      </p:sp>
+      <p:pic>
+        <p:nvPicPr>
+          <p:cNvPr id="38" name="Picture 37">
+            <a:extLst>
+              <a:ext uri="{FF2B5EF4-FFF2-40B4-BE49-F238E27FC236}">
+                <a16:creationId xmlns:a16="http://schemas.microsoft.com/office/drawing/2014/main" id="{93BF4FC7-6468-7696-BB19-15916C8F6277}"/>
+              </a:ext>
+            </a:extLst>
+          </p:cNvPr>
+          <p:cNvPicPr>
+            <a:picLocks noChangeAspect="1"/>
+          </p:cNvPicPr>
+          <p:nvPr/>
+        </p:nvPicPr>
+        <p:blipFill>
+          <a:blip r:embed="rId6"/>
+          <a:stretch>
+            <a:fillRect/>
+          </a:stretch>
+        </p:blipFill>
+        <p:spPr>
+          <a:xfrm>
+            <a:off x="4252514" y="2984478"/>
+            <a:ext cx="3005468" cy="2765901"/>
+          </a:xfrm>
+          <a:prstGeom prst="rect">
+            <a:avLst/>
+          </a:prstGeom>
+        </p:spPr>
+      </p:pic>
+      <p:pic>
+        <p:nvPicPr>
+          <p:cNvPr id="40" name="Picture 39">
+            <a:extLst>
+              <a:ext uri="{FF2B5EF4-FFF2-40B4-BE49-F238E27FC236}">
+                <a16:creationId xmlns:a16="http://schemas.microsoft.com/office/drawing/2014/main" id="{829CA63C-F096-989C-349A-3573BFE3D272}"/>
+              </a:ext>
+            </a:extLst>
+          </p:cNvPr>
+          <p:cNvPicPr>
+            <a:picLocks noChangeAspect="1"/>
+          </p:cNvPicPr>
+          <p:nvPr/>
+        </p:nvPicPr>
+        <p:blipFill>
+          <a:blip r:embed="rId7"/>
+          <a:stretch>
+            <a:fillRect/>
+          </a:stretch>
+        </p:blipFill>
+        <p:spPr>
+          <a:xfrm>
+            <a:off x="7105908" y="2700822"/>
+            <a:ext cx="4320386" cy="3209839"/>
           </a:xfrm>
           <a:prstGeom prst="rect">
             <a:avLst/>
@@ -3599,6 +3965,548 @@
 </file>
 
 <file path=ppt/slides/slide3.xml><?xml version="1.0" encoding="utf-8"?>
+<p:sld xmlns:a="http://schemas.openxmlformats.org/drawingml/2006/main" xmlns:r="http://schemas.openxmlformats.org/officeDocument/2006/relationships" xmlns:p="http://schemas.openxmlformats.org/presentationml/2006/main">
+  <p:cSld>
+    <p:spTree>
+      <p:nvGrpSpPr>
+        <p:cNvPr id="1" name="">
+          <a:extLst>
+            <a:ext uri="{FF2B5EF4-FFF2-40B4-BE49-F238E27FC236}">
+              <a16:creationId xmlns:a16="http://schemas.microsoft.com/office/drawing/2014/main" id="{E2434D7B-A459-7512-807A-148DA31D18DA}"/>
+            </a:ext>
+          </a:extLst>
+        </p:cNvPr>
+        <p:cNvGrpSpPr/>
+        <p:nvPr/>
+      </p:nvGrpSpPr>
+      <p:grpSpPr>
+        <a:xfrm>
+          <a:off x="0" y="0"/>
+          <a:ext cx="0" cy="0"/>
+          <a:chOff x="0" y="0"/>
+          <a:chExt cx="0" cy="0"/>
+        </a:xfrm>
+      </p:grpSpPr>
+      <p:sp>
+        <p:nvSpPr>
+          <p:cNvPr id="4" name="TextBox 3">
+            <a:extLst>
+              <a:ext uri="{FF2B5EF4-FFF2-40B4-BE49-F238E27FC236}">
+                <a16:creationId xmlns:a16="http://schemas.microsoft.com/office/drawing/2014/main" id="{47FE1231-68B5-B069-454D-1810F6701CE3}"/>
+              </a:ext>
+            </a:extLst>
+          </p:cNvPr>
+          <p:cNvSpPr txBox="1"/>
+          <p:nvPr/>
+        </p:nvSpPr>
+        <p:spPr>
+          <a:xfrm>
+            <a:off x="702087" y="268899"/>
+            <a:ext cx="1762598" cy="369332"/>
+          </a:xfrm>
+          <a:prstGeom prst="rect">
+            <a:avLst/>
+          </a:prstGeom>
+          <a:noFill/>
+        </p:spPr>
+        <p:txBody>
+          <a:bodyPr wrap="none" rtlCol="0">
+            <a:spAutoFit/>
+          </a:bodyPr>
+          <a:lstStyle/>
+          <a:p>
+            <a:r>
+              <a:rPr lang="en-US" b="1" dirty="0"/>
+              <a:t>Single material</a:t>
+            </a:r>
+          </a:p>
+        </p:txBody>
+      </p:sp>
+      <p:sp>
+        <p:nvSpPr>
+          <p:cNvPr id="6" name="TextBox 5">
+            <a:extLst>
+              <a:ext uri="{FF2B5EF4-FFF2-40B4-BE49-F238E27FC236}">
+                <a16:creationId xmlns:a16="http://schemas.microsoft.com/office/drawing/2014/main" id="{5FB26E57-8C05-58F7-0F22-169C6E137E7E}"/>
+              </a:ext>
+            </a:extLst>
+          </p:cNvPr>
+          <p:cNvSpPr txBox="1"/>
+          <p:nvPr/>
+        </p:nvSpPr>
+        <p:spPr>
+          <a:xfrm>
+            <a:off x="5981071" y="45908"/>
+            <a:ext cx="3456972" cy="369332"/>
+          </a:xfrm>
+          <a:prstGeom prst="rect">
+            <a:avLst/>
+          </a:prstGeom>
+          <a:noFill/>
+        </p:spPr>
+        <p:txBody>
+          <a:bodyPr wrap="none" rtlCol="0">
+            <a:spAutoFit/>
+          </a:bodyPr>
+          <a:lstStyle/>
+          <a:p>
+            <a:r>
+              <a:rPr lang="en-US" b="1" dirty="0"/>
+              <a:t>Multiple materials (No thermal)</a:t>
+            </a:r>
+          </a:p>
+        </p:txBody>
+      </p:sp>
+      <p:sp>
+        <p:nvSpPr>
+          <p:cNvPr id="2" name="TextBox 1">
+            <a:extLst>
+              <a:ext uri="{FF2B5EF4-FFF2-40B4-BE49-F238E27FC236}">
+                <a16:creationId xmlns:a16="http://schemas.microsoft.com/office/drawing/2014/main" id="{DF3B0E57-9013-D9E1-7144-A7F6ADAC6B65}"/>
+              </a:ext>
+            </a:extLst>
+          </p:cNvPr>
+          <p:cNvSpPr txBox="1"/>
+          <p:nvPr/>
+        </p:nvSpPr>
+        <p:spPr>
+          <a:xfrm>
+            <a:off x="1165331" y="647288"/>
+            <a:ext cx="1225015" cy="923330"/>
+          </a:xfrm>
+          <a:prstGeom prst="rect">
+            <a:avLst/>
+          </a:prstGeom>
+          <a:noFill/>
+        </p:spPr>
+        <p:txBody>
+          <a:bodyPr wrap="none" rtlCol="0">
+            <a:spAutoFit/>
+          </a:bodyPr>
+          <a:lstStyle/>
+          <a:p>
+            <a:r>
+              <a:rPr lang="en-US" b="1" dirty="0"/>
+              <a:t>E = 2.1e11</a:t>
+            </a:r>
+          </a:p>
+          <a:p>
+            <a:r>
+              <a:rPr lang="en-US" b="1" dirty="0"/>
+              <a:t>Y = 2.5e8</a:t>
+            </a:r>
+          </a:p>
+          <a:p>
+            <a:r>
+              <a:rPr lang="en-US" b="1" dirty="0">
+                <a:latin typeface="Symbol" panose="05050102010706020507" pitchFamily="18" charset="2"/>
+              </a:rPr>
+              <a:t>r</a:t>
+            </a:r>
+            <a:r>
+              <a:rPr lang="en-US" b="1" dirty="0"/>
+              <a:t> = 7850</a:t>
+            </a:r>
+          </a:p>
+        </p:txBody>
+      </p:sp>
+      <p:graphicFrame>
+        <p:nvGraphicFramePr>
+          <p:cNvPr id="7" name="Object 6">
+            <a:extLst>
+              <a:ext uri="{FF2B5EF4-FFF2-40B4-BE49-F238E27FC236}">
+                <a16:creationId xmlns:a16="http://schemas.microsoft.com/office/drawing/2014/main" id="{3CEEC0F1-9A36-1817-1822-894260623721}"/>
+              </a:ext>
+            </a:extLst>
+          </p:cNvPr>
+          <p:cNvGraphicFramePr>
+            <a:graphicFrameLocks noChangeAspect="1"/>
+          </p:cNvGraphicFramePr>
+          <p:nvPr>
+            <p:extLst>
+              <p:ext uri="{D42A27DB-BD31-4B8C-83A1-F6EECF244321}">
+                <p14:modId xmlns:p14="http://schemas.microsoft.com/office/powerpoint/2010/main" val="1722789260"/>
+              </p:ext>
+            </p:extLst>
+          </p:nvPr>
+        </p:nvGraphicFramePr>
+        <p:xfrm>
+          <a:off x="1165331" y="2040480"/>
+          <a:ext cx="1196637" cy="739739"/>
+        </p:xfrm>
+        <a:graphic>
+          <a:graphicData uri="http://schemas.openxmlformats.org/presentationml/2006/ole">
+            <mc:AlternateContent xmlns:mc="http://schemas.openxmlformats.org/markup-compatibility/2006">
+              <mc:Choice xmlns:v="urn:schemas-microsoft-com:vml" Requires="v">
+                <p:oleObj name="Equation" r:id="rId2" imgW="698400" imgH="431640" progId="Equation.DSMT4">
+                  <p:embed/>
+                </p:oleObj>
+              </mc:Choice>
+              <mc:Fallback>
+                <p:oleObj name="Equation" r:id="rId2" imgW="698400" imgH="431640" progId="Equation.DSMT4">
+                  <p:embed/>
+                  <p:pic>
+                    <p:nvPicPr>
+                      <p:cNvPr id="7" name="Object 6">
+                        <a:extLst>
+                          <a:ext uri="{FF2B5EF4-FFF2-40B4-BE49-F238E27FC236}">
+                            <a16:creationId xmlns:a16="http://schemas.microsoft.com/office/drawing/2014/main" id="{5761FA89-8ECE-52A1-A767-749A311401C8}"/>
+                          </a:ext>
+                        </a:extLst>
+                      </p:cNvPr>
+                      <p:cNvPicPr/>
+                      <p:nvPr/>
+                    </p:nvPicPr>
+                    <p:blipFill>
+                      <a:blip r:embed="rId3"/>
+                      <a:stretch>
+                        <a:fillRect/>
+                      </a:stretch>
+                    </p:blipFill>
+                    <p:spPr>
+                      <a:xfrm>
+                        <a:off x="1165331" y="2040480"/>
+                        <a:ext cx="1196637" cy="739739"/>
+                      </a:xfrm>
+                      <a:prstGeom prst="rect">
+                        <a:avLst/>
+                      </a:prstGeom>
+                    </p:spPr>
+                  </p:pic>
+                </p:oleObj>
+              </mc:Fallback>
+            </mc:AlternateContent>
+          </a:graphicData>
+        </a:graphic>
+      </p:graphicFrame>
+      <p:pic>
+        <p:nvPicPr>
+          <p:cNvPr id="12" name="Picture 11">
+            <a:extLst>
+              <a:ext uri="{FF2B5EF4-FFF2-40B4-BE49-F238E27FC236}">
+                <a16:creationId xmlns:a16="http://schemas.microsoft.com/office/drawing/2014/main" id="{F4800BF5-0164-DB93-4CE8-BDA5F1FAC5EE}"/>
+              </a:ext>
+            </a:extLst>
+          </p:cNvPr>
+          <p:cNvPicPr>
+            <a:picLocks noChangeAspect="1"/>
+          </p:cNvPicPr>
+          <p:nvPr/>
+        </p:nvPicPr>
+        <p:blipFill>
+          <a:blip r:embed="rId4"/>
+          <a:stretch>
+            <a:fillRect/>
+          </a:stretch>
+        </p:blipFill>
+        <p:spPr>
+          <a:xfrm>
+            <a:off x="4517166" y="442769"/>
+            <a:ext cx="5651686" cy="1168419"/>
+          </a:xfrm>
+          <a:prstGeom prst="rect">
+            <a:avLst/>
+          </a:prstGeom>
+        </p:spPr>
+      </p:pic>
+      <p:sp>
+        <p:nvSpPr>
+          <p:cNvPr id="14" name="TextBox 13">
+            <a:extLst>
+              <a:ext uri="{FF2B5EF4-FFF2-40B4-BE49-F238E27FC236}">
+                <a16:creationId xmlns:a16="http://schemas.microsoft.com/office/drawing/2014/main" id="{2C97D4F1-8B92-EECA-0FF7-43CF3FCA4D0C}"/>
+              </a:ext>
+            </a:extLst>
+          </p:cNvPr>
+          <p:cNvSpPr txBox="1"/>
+          <p:nvPr/>
+        </p:nvSpPr>
+        <p:spPr>
+          <a:xfrm>
+            <a:off x="10168852" y="906515"/>
+            <a:ext cx="1817101" cy="369332"/>
+          </a:xfrm>
+          <a:prstGeom prst="rect">
+            <a:avLst/>
+          </a:prstGeom>
+          <a:noFill/>
+        </p:spPr>
+        <p:txBody>
+          <a:bodyPr wrap="none" rtlCol="0">
+            <a:spAutoFit/>
+          </a:bodyPr>
+          <a:lstStyle/>
+          <a:p>
+            <a:r>
+              <a:rPr lang="en-US" dirty="0"/>
+              <a:t>2D latent space</a:t>
+            </a:r>
+          </a:p>
+        </p:txBody>
+      </p:sp>
+      <p:sp>
+        <p:nvSpPr>
+          <p:cNvPr id="15" name="Rectangle 14">
+            <a:extLst>
+              <a:ext uri="{FF2B5EF4-FFF2-40B4-BE49-F238E27FC236}">
+                <a16:creationId xmlns:a16="http://schemas.microsoft.com/office/drawing/2014/main" id="{61D199AC-7C01-311D-11FE-561B5756CEB1}"/>
+              </a:ext>
+            </a:extLst>
+          </p:cNvPr>
+          <p:cNvSpPr/>
+          <p:nvPr/>
+        </p:nvSpPr>
+        <p:spPr>
+          <a:xfrm>
+            <a:off x="4517166" y="904672"/>
+            <a:ext cx="5651686" cy="204281"/>
+          </a:xfrm>
+          <a:prstGeom prst="rect">
+            <a:avLst/>
+          </a:prstGeom>
+          <a:noFill/>
+          <a:ln>
+            <a:solidFill>
+              <a:srgbClr val="FF0000"/>
+            </a:solidFill>
+          </a:ln>
+        </p:spPr>
+        <p:style>
+          <a:lnRef idx="2">
+            <a:schemeClr val="accent1">
+              <a:shade val="15000"/>
+            </a:schemeClr>
+          </a:lnRef>
+          <a:fillRef idx="1">
+            <a:schemeClr val="accent1"/>
+          </a:fillRef>
+          <a:effectRef idx="0">
+            <a:schemeClr val="accent1"/>
+          </a:effectRef>
+          <a:fontRef idx="minor">
+            <a:schemeClr val="lt1"/>
+          </a:fontRef>
+        </p:style>
+        <p:txBody>
+          <a:bodyPr rtlCol="0" anchor="ctr"/>
+          <a:lstStyle/>
+          <a:p>
+            <a:pPr algn="ctr"/>
+            <a:endParaRPr lang="en-US">
+              <a:noFill/>
+            </a:endParaRPr>
+          </a:p>
+        </p:txBody>
+      </p:sp>
+      <p:sp>
+        <p:nvSpPr>
+          <p:cNvPr id="23" name="TextBox 22">
+            <a:extLst>
+              <a:ext uri="{FF2B5EF4-FFF2-40B4-BE49-F238E27FC236}">
+                <a16:creationId xmlns:a16="http://schemas.microsoft.com/office/drawing/2014/main" id="{AC5A66D1-454F-BEE3-7535-52456B6A8312}"/>
+              </a:ext>
+            </a:extLst>
+          </p:cNvPr>
+          <p:cNvSpPr txBox="1"/>
+          <p:nvPr/>
+        </p:nvSpPr>
+        <p:spPr>
+          <a:xfrm>
+            <a:off x="1243878" y="5887546"/>
+            <a:ext cx="1135247" cy="646331"/>
+          </a:xfrm>
+          <a:prstGeom prst="rect">
+            <a:avLst/>
+          </a:prstGeom>
+          <a:noFill/>
+        </p:spPr>
+        <p:txBody>
+          <a:bodyPr wrap="none" rtlCol="0">
+            <a:spAutoFit/>
+          </a:bodyPr>
+          <a:lstStyle/>
+          <a:p>
+            <a:r>
+              <a:rPr lang="en-US" b="1" dirty="0"/>
+              <a:t>M* = 24.5</a:t>
+            </a:r>
+          </a:p>
+          <a:p>
+            <a:r>
+              <a:rPr lang="en-US" b="1" dirty="0">
+                <a:latin typeface="Symbol" panose="05050102010706020507" pitchFamily="18" charset="2"/>
+              </a:rPr>
+              <a:t>s</a:t>
+            </a:r>
+            <a:r>
+              <a:rPr lang="en-US" b="1" dirty="0"/>
+              <a:t>*= 0.76</a:t>
+            </a:r>
+          </a:p>
+        </p:txBody>
+      </p:sp>
+      <p:sp>
+        <p:nvSpPr>
+          <p:cNvPr id="24" name="TextBox 23">
+            <a:extLst>
+              <a:ext uri="{FF2B5EF4-FFF2-40B4-BE49-F238E27FC236}">
+                <a16:creationId xmlns:a16="http://schemas.microsoft.com/office/drawing/2014/main" id="{6D234F66-E6CD-252A-3642-B3CAF7711F8A}"/>
+              </a:ext>
+            </a:extLst>
+          </p:cNvPr>
+          <p:cNvSpPr txBox="1"/>
+          <p:nvPr/>
+        </p:nvSpPr>
+        <p:spPr>
+          <a:xfrm>
+            <a:off x="5209377" y="5877727"/>
+            <a:ext cx="1135247" cy="646331"/>
+          </a:xfrm>
+          <a:prstGeom prst="rect">
+            <a:avLst/>
+          </a:prstGeom>
+          <a:noFill/>
+        </p:spPr>
+        <p:txBody>
+          <a:bodyPr wrap="none" rtlCol="0">
+            <a:spAutoFit/>
+          </a:bodyPr>
+          <a:lstStyle/>
+          <a:p>
+            <a:r>
+              <a:rPr lang="en-US" b="1" dirty="0"/>
+              <a:t>M* = 20.4</a:t>
+            </a:r>
+          </a:p>
+          <a:p>
+            <a:r>
+              <a:rPr lang="en-US" b="1" dirty="0">
+                <a:latin typeface="Symbol" panose="05050102010706020507" pitchFamily="18" charset="2"/>
+              </a:rPr>
+              <a:t>s</a:t>
+            </a:r>
+            <a:r>
+              <a:rPr lang="en-US" b="1" dirty="0"/>
+              <a:t>*= 0.77</a:t>
+            </a:r>
+            <a:endParaRPr lang="en-US" b="1" dirty="0">
+              <a:solidFill>
+                <a:srgbClr val="FF0000"/>
+              </a:solidFill>
+            </a:endParaRPr>
+          </a:p>
+        </p:txBody>
+      </p:sp>
+      <p:sp>
+        <p:nvSpPr>
+          <p:cNvPr id="26" name="TextBox 25">
+            <a:extLst>
+              <a:ext uri="{FF2B5EF4-FFF2-40B4-BE49-F238E27FC236}">
+                <a16:creationId xmlns:a16="http://schemas.microsoft.com/office/drawing/2014/main" id="{345D9CB2-D2B2-3773-189D-0EF85C41220C}"/>
+              </a:ext>
+            </a:extLst>
+          </p:cNvPr>
+          <p:cNvSpPr txBox="1"/>
+          <p:nvPr/>
+        </p:nvSpPr>
+        <p:spPr>
+          <a:xfrm>
+            <a:off x="6472896" y="1855814"/>
+            <a:ext cx="1570173" cy="369332"/>
+          </a:xfrm>
+          <a:prstGeom prst="rect">
+            <a:avLst/>
+          </a:prstGeom>
+          <a:noFill/>
+        </p:spPr>
+        <p:txBody>
+          <a:bodyPr wrap="none" rtlCol="0">
+            <a:spAutoFit/>
+          </a:bodyPr>
+          <a:lstStyle/>
+          <a:p>
+            <a:pPr algn="ctr"/>
+            <a:r>
+              <a:rPr lang="en-US" b="1" dirty="0"/>
+              <a:t>Init: Heaviest</a:t>
+            </a:r>
+          </a:p>
+        </p:txBody>
+      </p:sp>
+      <p:pic>
+        <p:nvPicPr>
+          <p:cNvPr id="8" name="Picture 7">
+            <a:extLst>
+              <a:ext uri="{FF2B5EF4-FFF2-40B4-BE49-F238E27FC236}">
+                <a16:creationId xmlns:a16="http://schemas.microsoft.com/office/drawing/2014/main" id="{1AD040ED-93B8-BD3C-841B-89907BBE4EB1}"/>
+              </a:ext>
+            </a:extLst>
+          </p:cNvPr>
+          <p:cNvPicPr>
+            <a:picLocks noChangeAspect="1"/>
+          </p:cNvPicPr>
+          <p:nvPr/>
+        </p:nvPicPr>
+        <p:blipFill>
+          <a:blip r:embed="rId5"/>
+          <a:stretch>
+            <a:fillRect/>
+          </a:stretch>
+        </p:blipFill>
+        <p:spPr>
+          <a:xfrm>
+            <a:off x="451780" y="2717036"/>
+            <a:ext cx="3682475" cy="3233693"/>
+          </a:xfrm>
+          <a:prstGeom prst="rect">
+            <a:avLst/>
+          </a:prstGeom>
+        </p:spPr>
+      </p:pic>
+      <p:pic>
+        <p:nvPicPr>
+          <p:cNvPr id="10" name="Picture 9">
+            <a:extLst>
+              <a:ext uri="{FF2B5EF4-FFF2-40B4-BE49-F238E27FC236}">
+                <a16:creationId xmlns:a16="http://schemas.microsoft.com/office/drawing/2014/main" id="{5F1C6EBE-BA07-D27B-6C34-7025F60A35ED}"/>
+              </a:ext>
+            </a:extLst>
+          </p:cNvPr>
+          <p:cNvPicPr>
+            <a:picLocks noChangeAspect="1"/>
+          </p:cNvPicPr>
+          <p:nvPr/>
+        </p:nvPicPr>
+        <p:blipFill>
+          <a:blip r:embed="rId6"/>
+          <a:stretch>
+            <a:fillRect/>
+          </a:stretch>
+        </p:blipFill>
+        <p:spPr>
+          <a:xfrm>
+            <a:off x="4599389" y="2464908"/>
+            <a:ext cx="3180659" cy="3192916"/>
+          </a:xfrm>
+          <a:prstGeom prst="rect">
+            <a:avLst/>
+          </a:prstGeom>
+        </p:spPr>
+      </p:pic>
+    </p:spTree>
+    <p:extLst>
+      <p:ext uri="{BB962C8B-B14F-4D97-AF65-F5344CB8AC3E}">
+        <p14:creationId xmlns:p14="http://schemas.microsoft.com/office/powerpoint/2010/main" val="3859539046"/>
+      </p:ext>
+    </p:extLst>
+  </p:cSld>
+  <p:clrMapOvr>
+    <a:masterClrMapping/>
+  </p:clrMapOvr>
+</p:sld>
+</file>
+
+<file path=ppt/slides/slide4.xml><?xml version="1.0" encoding="utf-8"?>
 <p:sld xmlns:a="http://schemas.openxmlformats.org/drawingml/2006/main" xmlns:r="http://schemas.openxmlformats.org/officeDocument/2006/relationships" xmlns:p="http://schemas.openxmlformats.org/presentationml/2006/main">
   <p:cSld>
     <p:spTree>
@@ -3754,7 +4662,7 @@
 </p:sld>
 </file>
 
-<file path=ppt/slides/slide4.xml><?xml version="1.0" encoding="utf-8"?>
+<file path=ppt/slides/slide5.xml><?xml version="1.0" encoding="utf-8"?>
 <p:sld xmlns:a="http://schemas.openxmlformats.org/drawingml/2006/main" xmlns:r="http://schemas.openxmlformats.org/officeDocument/2006/relationships" xmlns:p="http://schemas.openxmlformats.org/presentationml/2006/main">
   <p:cSld>
     <p:spTree>

</xml_diff>